<commit_message>
Fix the chart XML PowerPoint was rejecting
A duplicate dispBlanksAs sat after showDLblsOverMax inside c:chart.
CT_Chart is a sequence, so PowerPoint refused the file while LibreOffice
opened it, which is why it passed every render.

FINAL_slide8 is rebuilt from the corrected builder. The range-led variant
carried the same defect and is repaired in place, one element removed and
one reinserted in the right slot, nothing else touched.

Every deck in the repo now validates: chart element order, table cell
property order, content types and relationship targets.
</commit_message>
<xml_diff>
--- a/JGB_2s10s_Steepener_Range.pptx
+++ b/JGB_2s10s_Steepener_Range.pptx
@@ -108,7 +108,7 @@
 </file>
 
 <file path=ppt/charts/chart1.xml><?xml version="1.0" encoding="utf-8"?>
-<c:chartSpace xmlns:c="http://schemas.openxmlformats.org/drawingml/2006/chart" xmlns:a="http://schemas.openxmlformats.org/drawingml/2006/main" xmlns:r="http://schemas.openxmlformats.org/officeDocument/2006/relationships">
+<c:chartSpace xmlns:c="http://schemas.openxmlformats.org/drawingml/2006/chart" xmlns:ns1="http://schemas.openxmlformats.org/drawingml/2006/main" xmlns:ns2="http://schemas.openxmlformats.org/officeDocument/2006/relationships">
   <c:date1904 val="0"/>
   <c:chart>
     <c:autoTitleDeleted val="1"/>
@@ -131,11 +131,11 @@
             </c:strRef>
           </c:tx>
           <c:spPr>
-            <a:ln w="15875">
-              <a:solidFill>
-                <a:srgbClr val="767576"/>
-              </a:solidFill>
-            </a:ln>
+            <ns1:ln w="15875">
+              <ns1:solidFill>
+                <ns1:srgbClr val="767576"/>
+              </ns1:solidFill>
+            </ns1:ln>
           </c:spPr>
           <c:marker>
             <c:symbol val="none"/>
@@ -660,11 +660,11 @@
             </c:strRef>
           </c:tx>
           <c:spPr>
-            <a:ln w="28575">
-              <a:solidFill>
-                <a:srgbClr val="44546A"/>
-              </a:solidFill>
-            </a:ln>
+            <ns1:ln w="28575">
+              <ns1:solidFill>
+                <ns1:srgbClr val="44546A"/>
+              </ns1:solidFill>
+            </ns1:ln>
           </c:spPr>
           <c:marker>
             <c:symbol val="none"/>
@@ -1189,12 +1189,12 @@
             </c:strRef>
           </c:tx>
           <c:spPr>
-            <a:ln w="25400">
-              <a:solidFill>
-                <a:srgbClr val="DB0011"/>
-              </a:solidFill>
-              <a:prstDash val="dash"/>
-            </a:ln>
+            <ns1:ln w="25400">
+              <ns1:solidFill>
+                <ns1:srgbClr val="DB0011"/>
+              </ns1:solidFill>
+              <ns1:prstDash val="dash"/>
+            </ns1:ln>
           </c:spPr>
           <c:marker>
             <c:symbol val="none"/>
@@ -1720,11 +1720,11 @@
         <c:minorTickMark val="none"/>
         <c:tickLblPos val="none"/>
         <c:spPr>
-          <a:ln w="9525">
-            <a:solidFill>
-              <a:srgbClr val="000000"/>
-            </a:solidFill>
-          </a:ln>
+          <ns1:ln w="9525">
+            <ns1:solidFill>
+              <ns1:srgbClr val="000000"/>
+            </ns1:solidFill>
+          </ns1:ln>
         </c:spPr>
         <c:crossAx val="2140495176"/>
         <c:crosses val="autoZero"/>
@@ -1743,11 +1743,11 @@
         <c:axPos val="l"/>
         <c:majorGridlines>
           <c:spPr>
-            <a:ln w="6350">
-              <a:solidFill>
-                <a:srgbClr val="ECECEC"/>
-              </a:solidFill>
-            </a:ln>
+            <ns1:ln w="6350">
+              <ns1:solidFill>
+                <ns1:srgbClr val="ECECEC"/>
+              </ns1:solidFill>
+            </ns1:ln>
           </c:spPr>
         </c:majorGridlines>
         <c:numFmt formatCode="0.0&quot;%&quot;" sourceLinked="0"/>
@@ -1755,23 +1755,23 @@
         <c:minorTickMark val="none"/>
         <c:tickLblPos val="nextTo"/>
         <c:spPr>
-          <a:ln>
-            <a:noFill/>
-          </a:ln>
+          <ns1:ln>
+            <ns1:noFill/>
+          </ns1:ln>
         </c:spPr>
         <c:txPr>
-          <a:bodyPr/>
-          <a:lstStyle/>
-          <a:p>
-            <a:pPr>
-              <a:defRPr sz="850">
-                <a:solidFill>
-                  <a:srgbClr val="767576"/>
-                </a:solidFill>
-                <a:latin typeface="Arial"/>
-              </a:defRPr>
-            </a:pPr>
-          </a:p>
+          <ns1:bodyPr/>
+          <ns1:lstStyle/>
+          <ns1:p>
+            <ns1:pPr>
+              <ns1:defRPr sz="850">
+                <ns1:solidFill>
+                  <ns1:srgbClr val="767576"/>
+                </ns1:solidFill>
+                <ns1:latin typeface="Arial"/>
+              </ns1:defRPr>
+            </ns1:pPr>
+          </ns1:p>
         </c:txPr>
         <c:crossAx val="2118791784"/>
         <c:crosses val="autoZero"/>
@@ -1783,33 +1783,32 @@
       <c:layout/>
       <c:overlay val="0"/>
       <c:txPr>
-        <a:bodyPr/>
-        <a:lstStyle/>
-        <a:p>
-          <a:pPr>
-            <a:defRPr sz="850">
-              <a:latin typeface="Arial"/>
-            </a:defRPr>
-          </a:pPr>
-        </a:p>
+        <ns1:bodyPr/>
+        <ns1:lstStyle/>
+        <ns1:p>
+          <ns1:pPr>
+            <ns1:defRPr sz="850">
+              <ns1:latin typeface="Arial"/>
+            </ns1:defRPr>
+          </ns1:pPr>
+        </ns1:p>
       </c:txPr>
     </c:legend>
     <c:plotVisOnly val="1"/>
     <c:dispBlanksAs val="gap"/>
     <c:showDLblsOverMax val="0"/>
-    <c:dispBlanksAs val="span"/>
   </c:chart>
   <c:txPr>
-    <a:bodyPr/>
-    <a:lstStyle/>
-    <a:p>
-      <a:pPr>
-        <a:defRPr sz="1800"/>
-      </a:pPr>
-      <a:endParaRPr lang="en-US"/>
-    </a:p>
+    <ns1:bodyPr/>
+    <ns1:lstStyle/>
+    <ns1:p>
+      <ns1:pPr>
+        <ns1:defRPr sz="1800"/>
+      </ns1:pPr>
+      <ns1:endParaRPr lang="en-US"/>
+    </ns1:p>
   </c:txPr>
-  <c:externalData r:id="rId1">
+  <c:externalData ns2:id="rId1">
     <c:autoUpdate val="0"/>
   </c:externalData>
 </c:chartSpace>

</xml_diff>